<commit_message>
chore: consolidate demo names in deck and guides; rebuild deck
</commit_message>
<xml_diff>
--- a/training-materials/agentic-ai-workshop/Agentic-AI-LLM-Economics.pptx
+++ b/training-materials/agentic-ai-workshop/Agentic-AI-LLM-Economics.pptx
@@ -5978,7 +5978,7 @@
                 <a:ea typeface="Courier New" pitchFamily="34" charset="-122"/>
                 <a:cs typeface="Courier New" pitchFamily="34" charset="-120"/>
               </a:rPr>
-              <a:t>python demos/demo1_tokens_and_cost.py</a:t>
+              <a:t>python demos/01_tokens_and_cost.py</a:t>
             </a:r>
             <a:endParaRPr lang="en-US" sz="1300" dirty="0"/>
           </a:p>
@@ -8743,7 +8743,7 @@
                 <a:ea typeface="Courier New" pitchFamily="34" charset="-122"/>
                 <a:cs typeface="Courier New" pitchFamily="34" charset="-120"/>
               </a:rPr>
-              <a:t>python demos/demo3_rag_basic_vs_advanced.py</a:t>
+              <a:t>python demos/03_rag_basic_vs_advanced.py</a:t>
             </a:r>
             <a:endParaRPr lang="en-US" sz="1300" dirty="0"/>
           </a:p>
@@ -9767,7 +9767,7 @@
                 <a:ea typeface="Courier New" pitchFamily="34" charset="-122"/>
                 <a:cs typeface="Courier New" pitchFamily="34" charset="-120"/>
               </a:rPr>
-              <a:t>python demos/demo4_hybrid_router.py</a:t>
+              <a:t>python demos/04_router.py</a:t>
             </a:r>
             <a:endParaRPr lang="en-US" sz="1300" dirty="0"/>
           </a:p>
@@ -12654,7 +12654,7 @@
                 <a:ea typeface="Courier New" pitchFamily="34" charset="-122"/>
                 <a:cs typeface="Courier New" pitchFamily="34" charset="-120"/>
               </a:rPr>
-              <a:t>python demos/demo5_agent_with_rails.py</a:t>
+              <a:t>python demos/05_agent.py</a:t>
             </a:r>
             <a:endParaRPr lang="en-US" sz="1300" dirty="0"/>
           </a:p>
@@ -14060,7 +14060,7 @@
                 <a:ea typeface="Courier New" pitchFamily="34" charset="-122"/>
                 <a:cs typeface="Courier New" pitchFamily="34" charset="-120"/>
               </a:rPr>
-              <a:t>python demos/demo6_token_optimisation.py</a:t>
+              <a:t>python demos/06_routing_economics.py</a:t>
             </a:r>
             <a:endParaRPr lang="en-US" sz="1300" dirty="0"/>
           </a:p>
@@ -15896,7 +15896,7 @@
                 <a:ea typeface="Courier New" pitchFamily="34" charset="-122"/>
                 <a:cs typeface="Courier New" pitchFamily="34" charset="-120"/>
               </a:rPr>
-              <a:t>python demos/demo7_roi_and_plan.py</a:t>
+              <a:t>python demos/07_roi_and_plan.py</a:t>
             </a:r>
             <a:endParaRPr lang="en-US" sz="1300" dirty="0"/>
           </a:p>
@@ -17730,7 +17730,7 @@
                 <a:ea typeface="Courier New" pitchFamily="34" charset="-122"/>
                 <a:cs typeface="Courier New" pitchFamily="34" charset="-120"/>
               </a:rPr>
-              <a:t>python demos/demo2_hallucination.py</a:t>
+              <a:t>python demos/02_hallucination.py</a:t>
             </a:r>
             <a:endParaRPr lang="en-US" sz="1300" dirty="0"/>
           </a:p>

</xml_diff>